<commit_message>
Finished the diminishing return analysis.
</commit_message>
<xml_diff>
--- a/Conference/DroneDefibrillator_202610041700.pptx
+++ b/Conference/DroneDefibrillator_202610041700.pptx
@@ -6680,21 +6680,112 @@
           <a:chExt cx="0" cy="0"/>
         </a:xfrm>
       </p:grpSpPr>
+      <p:sp>
+        <p:nvSpPr>
+          <p:cNvPr id="8" name="TextBox 7">
+            <a:extLst>
+              <a:ext uri="{FF2B5EF4-FFF2-40B4-BE49-F238E27FC236}">
+                <a16:creationId xmlns:a16="http://schemas.microsoft.com/office/drawing/2014/main" id="{9E4F8137-F77C-9F2D-AA83-A51F88FDFF07}"/>
+              </a:ext>
+            </a:extLst>
+          </p:cNvPr>
+          <p:cNvSpPr txBox="1"/>
+          <p:nvPr/>
+        </p:nvSpPr>
+        <p:spPr>
+          <a:xfrm>
+            <a:off x="1082843" y="747211"/>
+            <a:ext cx="11359644" cy="3785652"/>
+          </a:xfrm>
+          <a:prstGeom prst="rect">
+            <a:avLst/>
+          </a:prstGeom>
+          <a:noFill/>
+        </p:spPr>
+        <p:txBody>
+          <a:bodyPr wrap="square" rtlCol="0">
+            <a:spAutoFit/>
+          </a:bodyPr>
+          <a:lstStyle/>
+          <a:p>
+            <a:r>
+              <a:rPr lang="hu-HU" sz="6000" b="1" dirty="0"/>
+              <a:t>Automata külső </a:t>
+            </a:r>
+            <a:r>
+              <a:rPr lang="hu-HU" sz="6000" b="1" dirty="0" err="1"/>
+              <a:t>defibrillátor</a:t>
+            </a:r>
+            <a:r>
+              <a:rPr lang="hu-HU" sz="6000" b="1" dirty="0"/>
+              <a:t> (AED) kiszállítása drónnal:</a:t>
+            </a:r>
+            <a:br>
+              <a:rPr lang="hu-HU" sz="6000" dirty="0"/>
+            </a:br>
+            <a:r>
+              <a:rPr lang="hu-HU" sz="6000" dirty="0"/>
+              <a:t>Térinformatikai megoldások és operációkutatási optimalizálás</a:t>
+            </a:r>
+          </a:p>
+        </p:txBody>
+      </p:sp>
+      <p:sp>
+        <p:nvSpPr>
+          <p:cNvPr id="10" name="TextBox 9">
+            <a:extLst>
+              <a:ext uri="{FF2B5EF4-FFF2-40B4-BE49-F238E27FC236}">
+                <a16:creationId xmlns:a16="http://schemas.microsoft.com/office/drawing/2014/main" id="{EEA507D2-AD5E-3E91-338B-AFC8AB11FAB1}"/>
+              </a:ext>
+            </a:extLst>
+          </p:cNvPr>
+          <p:cNvSpPr txBox="1"/>
+          <p:nvPr/>
+        </p:nvSpPr>
+        <p:spPr>
+          <a:xfrm>
+            <a:off x="12757488" y="747210"/>
+            <a:ext cx="11359644" cy="3785652"/>
+          </a:xfrm>
+          <a:prstGeom prst="rect">
+            <a:avLst/>
+          </a:prstGeom>
+          <a:noFill/>
+        </p:spPr>
+        <p:txBody>
+          <a:bodyPr wrap="square" rtlCol="0">
+            <a:spAutoFit/>
+          </a:bodyPr>
+          <a:lstStyle/>
+          <a:p>
+            <a:r>
+              <a:rPr lang="en-US" sz="6000" b="1" dirty="0"/>
+              <a:t>Automated external defibrillator (AED) delivery by drone:</a:t>
+            </a:r>
+            <a:br>
+              <a:rPr lang="hu-HU" sz="6000" b="1" dirty="0"/>
+            </a:br>
+            <a:r>
+              <a:rPr lang="en-US" sz="6000" dirty="0"/>
+              <a:t>Geospatial solutions and operations research optimization</a:t>
+            </a:r>
+            <a:endParaRPr lang="hu-HU" sz="6000" dirty="0"/>
+          </a:p>
+        </p:txBody>
+      </p:sp>
       <p:pic>
         <p:nvPicPr>
-          <p:cNvPr id="57" name="Content Placeholder 56">
+          <p:cNvPr id="17" name="Content Placeholder 13">
             <a:extLst>
               <a:ext uri="{FF2B5EF4-FFF2-40B4-BE49-F238E27FC236}">
-                <a16:creationId xmlns:a16="http://schemas.microsoft.com/office/drawing/2014/main" id="{CF282539-AA82-B1A2-BF8F-2468D02C3DE8}"/>
+                <a16:creationId xmlns:a16="http://schemas.microsoft.com/office/drawing/2014/main" id="{B8251EFD-B2CE-97E6-18C4-568387BA4C3A}"/>
               </a:ext>
             </a:extLst>
           </p:cNvPr>
           <p:cNvPicPr>
-            <a:picLocks noGrp="1" noChangeAspect="1"/>
+            <a:picLocks noChangeAspect="1"/>
           </p:cNvPicPr>
-          <p:nvPr>
-            <p:ph sz="half" idx="2"/>
-          </p:nvPr>
+          <p:nvPr/>
         </p:nvPicPr>
         <p:blipFill>
           <a:blip r:embed="rId2">
@@ -6710,136 +6801,7 @@
         </p:blipFill>
         <p:spPr>
           <a:xfrm>
-            <a:off x="11387731" y="42033845"/>
-            <a:ext cx="2582380" cy="1533525"/>
-          </a:xfrm>
-          <a:prstGeom prst="rect">
-            <a:avLst/>
-          </a:prstGeom>
-        </p:spPr>
-      </p:pic>
-      <p:sp>
-        <p:nvSpPr>
-          <p:cNvPr id="8" name="TextBox 7">
-            <a:extLst>
-              <a:ext uri="{FF2B5EF4-FFF2-40B4-BE49-F238E27FC236}">
-                <a16:creationId xmlns:a16="http://schemas.microsoft.com/office/drawing/2014/main" id="{9E4F8137-F77C-9F2D-AA83-A51F88FDFF07}"/>
-              </a:ext>
-            </a:extLst>
-          </p:cNvPr>
-          <p:cNvSpPr txBox="1"/>
-          <p:nvPr/>
-        </p:nvSpPr>
-        <p:spPr>
-          <a:xfrm>
-            <a:off x="1082843" y="747211"/>
-            <a:ext cx="11359644" cy="3785652"/>
-          </a:xfrm>
-          <a:prstGeom prst="rect">
-            <a:avLst/>
-          </a:prstGeom>
-          <a:noFill/>
-        </p:spPr>
-        <p:txBody>
-          <a:bodyPr wrap="square" rtlCol="0">
-            <a:spAutoFit/>
-          </a:bodyPr>
-          <a:lstStyle/>
-          <a:p>
-            <a:r>
-              <a:rPr lang="hu-HU" sz="6000" b="1" dirty="0"/>
-              <a:t>Automata külső </a:t>
-            </a:r>
-            <a:r>
-              <a:rPr lang="hu-HU" sz="6000" b="1" dirty="0" err="1"/>
-              <a:t>defibrillátor</a:t>
-            </a:r>
-            <a:r>
-              <a:rPr lang="hu-HU" sz="6000" b="1" dirty="0"/>
-              <a:t> (AED) kiszállítása drónnal:</a:t>
-            </a:r>
-            <a:br>
-              <a:rPr lang="hu-HU" sz="6000" dirty="0"/>
-            </a:br>
-            <a:r>
-              <a:rPr lang="hu-HU" sz="6000" dirty="0"/>
-              <a:t>Térinformatikai megoldások és operációkutatási optimalizálás</a:t>
-            </a:r>
-          </a:p>
-        </p:txBody>
-      </p:sp>
-      <p:sp>
-        <p:nvSpPr>
-          <p:cNvPr id="10" name="TextBox 9">
-            <a:extLst>
-              <a:ext uri="{FF2B5EF4-FFF2-40B4-BE49-F238E27FC236}">
-                <a16:creationId xmlns:a16="http://schemas.microsoft.com/office/drawing/2014/main" id="{EEA507D2-AD5E-3E91-338B-AFC8AB11FAB1}"/>
-              </a:ext>
-            </a:extLst>
-          </p:cNvPr>
-          <p:cNvSpPr txBox="1"/>
-          <p:nvPr/>
-        </p:nvSpPr>
-        <p:spPr>
-          <a:xfrm>
-            <a:off x="12757488" y="747210"/>
-            <a:ext cx="11359644" cy="3785652"/>
-          </a:xfrm>
-          <a:prstGeom prst="rect">
-            <a:avLst/>
-          </a:prstGeom>
-          <a:noFill/>
-        </p:spPr>
-        <p:txBody>
-          <a:bodyPr wrap="square" rtlCol="0">
-            <a:spAutoFit/>
-          </a:bodyPr>
-          <a:lstStyle/>
-          <a:p>
-            <a:r>
-              <a:rPr lang="en-US" sz="6000" b="1" dirty="0"/>
-              <a:t>Automated external defibrillator (AED) delivery by drone:</a:t>
-            </a:r>
-            <a:br>
-              <a:rPr lang="hu-HU" sz="6000" b="1" dirty="0"/>
-            </a:br>
-            <a:r>
-              <a:rPr lang="en-US" sz="6000" dirty="0"/>
-              <a:t>Geospatial solutions and operations research optimization</a:t>
-            </a:r>
-            <a:endParaRPr lang="hu-HU" sz="6000" dirty="0"/>
-          </a:p>
-        </p:txBody>
-      </p:sp>
-      <p:pic>
-        <p:nvPicPr>
-          <p:cNvPr id="17" name="Content Placeholder 13">
-            <a:extLst>
-              <a:ext uri="{FF2B5EF4-FFF2-40B4-BE49-F238E27FC236}">
-                <a16:creationId xmlns:a16="http://schemas.microsoft.com/office/drawing/2014/main" id="{B8251EFD-B2CE-97E6-18C4-568387BA4C3A}"/>
-              </a:ext>
-            </a:extLst>
-          </p:cNvPr>
-          <p:cNvPicPr>
-            <a:picLocks noChangeAspect="1"/>
-          </p:cNvPicPr>
-          <p:nvPr/>
-        </p:nvPicPr>
-        <p:blipFill>
-          <a:blip r:embed="rId3">
-            <a:extLst>
-              <a:ext uri="{28A0092B-C50C-407E-A947-70E740481C1C}">
-                <a14:useLocalDpi xmlns:a14="http://schemas.microsoft.com/office/drawing/2010/main" val="0"/>
-              </a:ext>
-            </a:extLst>
-          </a:blip>
-          <a:stretch>
-            <a:fillRect/>
-          </a:stretch>
-        </p:blipFill>
-        <p:spPr>
-          <a:xfrm>
-            <a:off x="10452896" y="6786864"/>
+            <a:off x="10452896" y="7508755"/>
             <a:ext cx="4294181" cy="4294181"/>
           </a:xfrm>
           <a:prstGeom prst="rect">
@@ -6847,42 +6809,6 @@
           </a:prstGeom>
         </p:spPr>
       </p:pic>
-      <p:sp>
-        <p:nvSpPr>
-          <p:cNvPr id="21" name="TextBox 20">
-            <a:extLst>
-              <a:ext uri="{FF2B5EF4-FFF2-40B4-BE49-F238E27FC236}">
-                <a16:creationId xmlns:a16="http://schemas.microsoft.com/office/drawing/2014/main" id="{EFEEC61B-4D65-8D2F-E602-0FA9508A49A9}"/>
-              </a:ext>
-            </a:extLst>
-          </p:cNvPr>
-          <p:cNvSpPr txBox="1"/>
-          <p:nvPr/>
-        </p:nvSpPr>
-        <p:spPr>
-          <a:xfrm>
-            <a:off x="561372" y="33236456"/>
-            <a:ext cx="11816845" cy="1015663"/>
-          </a:xfrm>
-          <a:prstGeom prst="rect">
-            <a:avLst/>
-          </a:prstGeom>
-          <a:noFill/>
-        </p:spPr>
-        <p:txBody>
-          <a:bodyPr wrap="square" rtlCol="0">
-            <a:spAutoFit/>
-          </a:bodyPr>
-          <a:lstStyle/>
-          <a:p>
-            <a:r>
-              <a:rPr lang="hu-HU" sz="6000" dirty="0" err="1"/>
-              <a:t>asasasas</a:t>
-            </a:r>
-            <a:endParaRPr lang="hu-HU" sz="6000" dirty="0"/>
-          </a:p>
-        </p:txBody>
-      </p:sp>
       <p:sp>
         <p:nvSpPr>
           <p:cNvPr id="25" name="TextBox 24">
@@ -6897,7 +6823,7 @@
         </p:nvSpPr>
         <p:spPr>
           <a:xfrm>
-            <a:off x="1082843" y="5771202"/>
+            <a:off x="1082843" y="6493093"/>
             <a:ext cx="7916778" cy="5032147"/>
           </a:xfrm>
           <a:prstGeom prst="rect">
@@ -6977,7 +6903,7 @@
         </p:nvSpPr>
         <p:spPr>
           <a:xfrm>
-            <a:off x="16200355" y="5771202"/>
+            <a:off x="16200355" y="6493093"/>
             <a:ext cx="7916778" cy="5032147"/>
           </a:xfrm>
           <a:prstGeom prst="rect">
@@ -7960,7 +7886,7 @@
         </p:nvSpPr>
         <p:spPr>
           <a:xfrm>
-            <a:off x="9727361" y="5771202"/>
+            <a:off x="9727361" y="6493093"/>
             <a:ext cx="2715123" cy="1015663"/>
           </a:xfrm>
           <a:prstGeom prst="rect">
@@ -7996,7 +7922,7 @@
         </p:nvSpPr>
         <p:spPr>
           <a:xfrm>
-            <a:off x="12757491" y="5771201"/>
+            <a:off x="12757491" y="6493092"/>
             <a:ext cx="2715120" cy="1015663"/>
           </a:xfrm>
           <a:prstGeom prst="rect">
@@ -8045,7 +7971,7 @@
         <p:spPr>
           <a:xfrm>
             <a:off x="1082842" y="4532862"/>
-            <a:ext cx="11359641" cy="1015663"/>
+            <a:ext cx="11359641" cy="1477328"/>
           </a:xfrm>
           <a:prstGeom prst="rect">
             <a:avLst/>
@@ -8068,6 +7994,13 @@
             <a:r>
               <a:rPr lang="hu-HU" sz="3000" dirty="0"/>
               <a:t>				Tokaj-Hegyalja Egyetem, Lorántffy Intézet</a:t>
+            </a:r>
+            <a:br>
+              <a:rPr lang="hu-HU" sz="3000" dirty="0"/>
+            </a:br>
+            <a:r>
+              <a:rPr lang="hu-HU" sz="3000" dirty="0"/>
+              <a:t>E-mail:		veres.zoltan@unithe.hu</a:t>
             </a:r>
           </a:p>
         </p:txBody>
@@ -8087,7 +8020,7 @@
         <p:spPr>
           <a:xfrm>
             <a:off x="12757491" y="4528720"/>
-            <a:ext cx="11359641" cy="1015663"/>
+            <a:ext cx="11359641" cy="1477328"/>
           </a:xfrm>
           <a:prstGeom prst="rect">
             <a:avLst/>
@@ -8113,6 +8046,13 @@
             <a:r>
               <a:rPr lang="hu-HU" sz="3000" dirty="0"/>
               <a:t>				University of Tokaj, Lorántffy Institute</a:t>
+            </a:r>
+            <a:br>
+              <a:rPr lang="hu-HU" sz="3000" dirty="0"/>
+            </a:br>
+            <a:r>
+              <a:rPr lang="hu-HU" sz="3000" dirty="0"/>
+              <a:t>E-mail:		veres.zoltan@unithe.hu</a:t>
             </a:r>
           </a:p>
         </p:txBody>
@@ -8132,14 +8072,14 @@
           <p:nvPr/>
         </p:nvPicPr>
         <p:blipFill>
-          <a:blip r:embed="rId4"/>
+          <a:blip r:embed="rId3"/>
           <a:stretch>
             <a:fillRect/>
           </a:stretch>
         </p:blipFill>
         <p:spPr>
           <a:xfrm>
-            <a:off x="6469795" y="12595811"/>
+            <a:off x="6469795" y="13341767"/>
             <a:ext cx="12260386" cy="7621064"/>
           </a:xfrm>
           <a:prstGeom prst="rect">
@@ -8161,7 +8101,7 @@
         </p:nvSpPr>
         <p:spPr>
           <a:xfrm>
-            <a:off x="1082843" y="11519020"/>
+            <a:off x="1082843" y="12264976"/>
             <a:ext cx="5386952" cy="8910131"/>
           </a:xfrm>
           <a:prstGeom prst="rect">
@@ -8349,7 +8289,7 @@
         </p:nvSpPr>
         <p:spPr>
           <a:xfrm>
-            <a:off x="18730180" y="11537030"/>
+            <a:off x="18730180" y="12282986"/>
             <a:ext cx="5386952" cy="8633133"/>
           </a:xfrm>
           <a:prstGeom prst="rect">
@@ -9405,6 +9345,42 @@
             <a:extLst>
               <a:ext uri="{FF2B5EF4-FFF2-40B4-BE49-F238E27FC236}">
                 <a16:creationId xmlns:a16="http://schemas.microsoft.com/office/drawing/2014/main" id="{4D35F4FE-4C26-A39E-AD24-C150FD1C2BA5}"/>
+              </a:ext>
+            </a:extLst>
+          </p:cNvPr>
+          <p:cNvPicPr>
+            <a:picLocks noChangeAspect="1"/>
+          </p:cNvPicPr>
+          <p:nvPr/>
+        </p:nvPicPr>
+        <p:blipFill>
+          <a:blip r:embed="rId4">
+            <a:extLst>
+              <a:ext uri="{28A0092B-C50C-407E-A947-70E740481C1C}">
+                <a14:useLocalDpi xmlns:a14="http://schemas.microsoft.com/office/drawing/2010/main" val="0"/>
+              </a:ext>
+            </a:extLst>
+          </a:blip>
+          <a:stretch>
+            <a:fillRect/>
+          </a:stretch>
+        </p:blipFill>
+        <p:spPr>
+          <a:xfrm>
+            <a:off x="8692650" y="22362286"/>
+            <a:ext cx="7712241" cy="4588868"/>
+          </a:xfrm>
+          <a:prstGeom prst="rect">
+            <a:avLst/>
+          </a:prstGeom>
+        </p:spPr>
+      </p:pic>
+      <p:pic>
+        <p:nvPicPr>
+          <p:cNvPr id="61" name="Picture 60">
+            <a:extLst>
+              <a:ext uri="{FF2B5EF4-FFF2-40B4-BE49-F238E27FC236}">
+                <a16:creationId xmlns:a16="http://schemas.microsoft.com/office/drawing/2014/main" id="{C0F58D32-F277-BD51-E6B6-DD0CD1957C5F}"/>
               </a:ext>
             </a:extLst>
           </p:cNvPr>
@@ -9427,8 +9403,8 @@
         </p:blipFill>
         <p:spPr>
           <a:xfrm>
-            <a:off x="8692650" y="20413169"/>
-            <a:ext cx="7712241" cy="4588868"/>
+            <a:off x="16404891" y="22386765"/>
+            <a:ext cx="7712242" cy="4539910"/>
           </a:xfrm>
           <a:prstGeom prst="rect">
             <a:avLst/>
@@ -9437,10 +9413,10 @@
       </p:pic>
       <p:pic>
         <p:nvPicPr>
-          <p:cNvPr id="61" name="Picture 60">
+          <p:cNvPr id="63" name="Picture 62">
             <a:extLst>
               <a:ext uri="{FF2B5EF4-FFF2-40B4-BE49-F238E27FC236}">
-                <a16:creationId xmlns:a16="http://schemas.microsoft.com/office/drawing/2014/main" id="{C0F58D32-F277-BD51-E6B6-DD0CD1957C5F}"/>
+                <a16:creationId xmlns:a16="http://schemas.microsoft.com/office/drawing/2014/main" id="{6EDEEB76-A5B3-6C7A-25FC-B431A9E768F1}"/>
               </a:ext>
             </a:extLst>
           </p:cNvPr>
@@ -9463,20 +9439,166 @@
         </p:blipFill>
         <p:spPr>
           <a:xfrm>
-            <a:off x="16404891" y="20437648"/>
-            <a:ext cx="7712242" cy="4539910"/>
+            <a:off x="1082843" y="22378268"/>
+            <a:ext cx="7609807" cy="4519021"/>
           </a:xfrm>
           <a:prstGeom prst="rect">
             <a:avLst/>
           </a:prstGeom>
         </p:spPr>
       </p:pic>
+      <p:sp>
+        <p:nvSpPr>
+          <p:cNvPr id="66" name="TextBox 65">
+            <a:extLst>
+              <a:ext uri="{FF2B5EF4-FFF2-40B4-BE49-F238E27FC236}">
+                <a16:creationId xmlns:a16="http://schemas.microsoft.com/office/drawing/2014/main" id="{584987C4-D766-E6A9-DA5D-F8BAD6AC26B8}"/>
+              </a:ext>
+            </a:extLst>
+          </p:cNvPr>
+          <p:cNvSpPr txBox="1"/>
+          <p:nvPr/>
+        </p:nvSpPr>
+        <p:spPr>
+          <a:xfrm>
+            <a:off x="1092328" y="21636864"/>
+            <a:ext cx="11359640" cy="784830"/>
+          </a:xfrm>
+          <a:prstGeom prst="rect">
+            <a:avLst/>
+          </a:prstGeom>
+          <a:noFill/>
+        </p:spPr>
+        <p:txBody>
+          <a:bodyPr wrap="square" rtlCol="0">
+            <a:spAutoFit/>
+          </a:bodyPr>
+          <a:lstStyle/>
+          <a:p>
+            <a:pPr algn="ctr"/>
+            <a:r>
+              <a:rPr lang="hu-HU" sz="4500" b="1" dirty="0"/>
+              <a:t>Eredmények</a:t>
+            </a:r>
+          </a:p>
+        </p:txBody>
+      </p:sp>
+      <p:sp>
+        <p:nvSpPr>
+          <p:cNvPr id="68" name="TextBox 67">
+            <a:extLst>
+              <a:ext uri="{FF2B5EF4-FFF2-40B4-BE49-F238E27FC236}">
+                <a16:creationId xmlns:a16="http://schemas.microsoft.com/office/drawing/2014/main" id="{BDF557F3-FA0A-B260-D94D-F7B0B569D7DF}"/>
+              </a:ext>
+            </a:extLst>
+          </p:cNvPr>
+          <p:cNvSpPr txBox="1"/>
+          <p:nvPr/>
+        </p:nvSpPr>
+        <p:spPr>
+          <a:xfrm>
+            <a:off x="12757492" y="21636864"/>
+            <a:ext cx="11359640" cy="784830"/>
+          </a:xfrm>
+          <a:prstGeom prst="rect">
+            <a:avLst/>
+          </a:prstGeom>
+          <a:noFill/>
+        </p:spPr>
+        <p:txBody>
+          <a:bodyPr wrap="square" rtlCol="0">
+            <a:spAutoFit/>
+          </a:bodyPr>
+          <a:lstStyle/>
+          <a:p>
+            <a:pPr algn="ctr"/>
+            <a:r>
+              <a:rPr lang="hu-HU" sz="4500" b="1" dirty="0" err="1"/>
+              <a:t>Results</a:t>
+            </a:r>
+            <a:endParaRPr lang="hu-HU" sz="4500" b="1" dirty="0"/>
+          </a:p>
+        </p:txBody>
+      </p:sp>
+      <p:sp>
+        <p:nvSpPr>
+          <p:cNvPr id="74" name="TextBox 73">
+            <a:extLst>
+              <a:ext uri="{FF2B5EF4-FFF2-40B4-BE49-F238E27FC236}">
+                <a16:creationId xmlns:a16="http://schemas.microsoft.com/office/drawing/2014/main" id="{D1D09206-8B4E-782A-B45A-4AB7E622AF37}"/>
+              </a:ext>
+            </a:extLst>
+          </p:cNvPr>
+          <p:cNvSpPr txBox="1"/>
+          <p:nvPr/>
+        </p:nvSpPr>
+        <p:spPr>
+          <a:xfrm>
+            <a:off x="1092328" y="27393546"/>
+            <a:ext cx="11359640" cy="784830"/>
+          </a:xfrm>
+          <a:prstGeom prst="rect">
+            <a:avLst/>
+          </a:prstGeom>
+          <a:noFill/>
+        </p:spPr>
+        <p:txBody>
+          <a:bodyPr wrap="square" rtlCol="0">
+            <a:spAutoFit/>
+          </a:bodyPr>
+          <a:lstStyle/>
+          <a:p>
+            <a:pPr algn="ctr"/>
+            <a:r>
+              <a:rPr lang="hu-HU" sz="4500" b="1" dirty="0"/>
+              <a:t>Konklúzió</a:t>
+            </a:r>
+          </a:p>
+        </p:txBody>
+      </p:sp>
+      <p:sp>
+        <p:nvSpPr>
+          <p:cNvPr id="76" name="TextBox 75">
+            <a:extLst>
+              <a:ext uri="{FF2B5EF4-FFF2-40B4-BE49-F238E27FC236}">
+                <a16:creationId xmlns:a16="http://schemas.microsoft.com/office/drawing/2014/main" id="{952DFDAB-C560-861F-91BD-B190527903DC}"/>
+              </a:ext>
+            </a:extLst>
+          </p:cNvPr>
+          <p:cNvSpPr txBox="1"/>
+          <p:nvPr/>
+        </p:nvSpPr>
+        <p:spPr>
+          <a:xfrm>
+            <a:off x="12757492" y="27393546"/>
+            <a:ext cx="11359640" cy="784830"/>
+          </a:xfrm>
+          <a:prstGeom prst="rect">
+            <a:avLst/>
+          </a:prstGeom>
+          <a:noFill/>
+        </p:spPr>
+        <p:txBody>
+          <a:bodyPr wrap="square" rtlCol="0">
+            <a:spAutoFit/>
+          </a:bodyPr>
+          <a:lstStyle/>
+          <a:p>
+            <a:pPr algn="ctr"/>
+            <a:r>
+              <a:rPr lang="hu-HU" sz="4500" b="1" dirty="0" err="1"/>
+              <a:t>Conclusion</a:t>
+            </a:r>
+            <a:endParaRPr lang="hu-HU" sz="4500" b="1" dirty="0"/>
+          </a:p>
+        </p:txBody>
+      </p:sp>
       <p:pic>
         <p:nvPicPr>
-          <p:cNvPr id="63" name="Picture 62">
+          <p:cNvPr id="78" name="Picture 77">
             <a:extLst>
               <a:ext uri="{FF2B5EF4-FFF2-40B4-BE49-F238E27FC236}">
-                <a16:creationId xmlns:a16="http://schemas.microsoft.com/office/drawing/2014/main" id="{6EDEEB76-A5B3-6C7A-25FC-B431A9E768F1}"/>
+                <a16:creationId xmlns:a16="http://schemas.microsoft.com/office/drawing/2014/main" id="{CC7E3213-FE0A-1AB3-93C0-40DDA52FCA8B}"/>
               </a:ext>
             </a:extLst>
           </p:cNvPr>
@@ -9486,7 +9608,7 @@
           <p:nvPr/>
         </p:nvPicPr>
         <p:blipFill>
-          <a:blip r:embed="rId2">
+          <a:blip r:embed="rId7">
             <a:extLst>
               <a:ext uri="{28A0092B-C50C-407E-A947-70E740481C1C}">
                 <a14:useLocalDpi xmlns:a14="http://schemas.microsoft.com/office/drawing/2010/main" val="0"/>
@@ -9499,14 +9621,195 @@
         </p:blipFill>
         <p:spPr>
           <a:xfrm>
-            <a:off x="1082843" y="20429151"/>
-            <a:ext cx="7609807" cy="4519021"/>
+            <a:off x="8032721" y="28109627"/>
+            <a:ext cx="9144019" cy="5486411"/>
           </a:xfrm>
           <a:prstGeom prst="rect">
             <a:avLst/>
           </a:prstGeom>
         </p:spPr>
       </p:pic>
+      <p:sp>
+        <p:nvSpPr>
+          <p:cNvPr id="80" name="TextBox 79">
+            <a:extLst>
+              <a:ext uri="{FF2B5EF4-FFF2-40B4-BE49-F238E27FC236}">
+                <a16:creationId xmlns:a16="http://schemas.microsoft.com/office/drawing/2014/main" id="{7CC296BF-BEE7-3B9C-B6D5-4D8135A66C5B}"/>
+              </a:ext>
+            </a:extLst>
+          </p:cNvPr>
+          <p:cNvSpPr txBox="1"/>
+          <p:nvPr/>
+        </p:nvSpPr>
+        <p:spPr>
+          <a:xfrm>
+            <a:off x="1095253" y="28176497"/>
+            <a:ext cx="6937468" cy="5632311"/>
+          </a:xfrm>
+          <a:prstGeom prst="rect">
+            <a:avLst/>
+          </a:prstGeom>
+          <a:noFill/>
+        </p:spPr>
+        <p:txBody>
+          <a:bodyPr wrap="square" rtlCol="0">
+            <a:spAutoFit/>
+          </a:bodyPr>
+          <a:lstStyle/>
+          <a:p>
+            <a:pPr algn="just"/>
+            <a:r>
+              <a:rPr lang="hu-HU" sz="2400" b="1" dirty="0"/>
+              <a:t>Matematikai optimum:</a:t>
+            </a:r>
+            <a:r>
+              <a:rPr lang="hu-HU" sz="2400" dirty="0"/>
+              <a:t> A hálózat optimalizálása során a csökkenő hozadék (</a:t>
+            </a:r>
+            <a:r>
+              <a:rPr lang="hu-HU" sz="2400" dirty="0" err="1"/>
+              <a:t>diminishing</a:t>
+            </a:r>
+            <a:r>
+              <a:rPr lang="hu-HU" sz="2400" dirty="0"/>
+              <a:t> </a:t>
+            </a:r>
+            <a:r>
+              <a:rPr lang="hu-HU" sz="2400" dirty="0" err="1"/>
+              <a:t>returns</a:t>
+            </a:r>
+            <a:r>
+              <a:rPr lang="hu-HU" sz="2400" dirty="0"/>
+              <a:t>) elve egyértelműen megmutatkozik a drónok hatótávja és a bázisigény között. Az ideális egyensúlyi pont (</a:t>
+            </a:r>
+            <a:r>
+              <a:rPr lang="hu-HU" sz="2400" dirty="0" err="1"/>
+              <a:t>sweet</a:t>
+            </a:r>
+            <a:r>
+              <a:rPr lang="hu-HU" sz="2400" dirty="0"/>
+              <a:t> spot) 16 km-es hatótávolságnál található.</a:t>
+            </a:r>
+          </a:p>
+          <a:p>
+            <a:pPr algn="just"/>
+            <a:r>
+              <a:rPr lang="hu-HU" sz="2400" b="1" dirty="0"/>
+              <a:t>Infrastrukturális igény: </a:t>
+            </a:r>
+            <a:r>
+              <a:rPr lang="hu-HU" sz="2400" dirty="0"/>
+              <a:t>Ezen a ponton az országos AED-kereslet 95%-os lefedéséhez 140 drónbázis telepítése szükséges.</a:t>
+            </a:r>
+          </a:p>
+          <a:p>
+            <a:pPr algn="just"/>
+            <a:r>
+              <a:rPr lang="hu-HU" sz="2400" b="1" dirty="0"/>
+              <a:t>Végső verdikt: </a:t>
+            </a:r>
+            <a:r>
+              <a:rPr lang="hu-HU" sz="2400" dirty="0"/>
+              <a:t>Egy kisméretű, 16-20 km hatósugarú eszközökre (pl. VTOL technológiára) épülő, </a:t>
+            </a:r>
+            <a:r>
+              <a:rPr lang="hu-HU" sz="2400" dirty="0" err="1"/>
+              <a:t>adatvezérelt</a:t>
+            </a:r>
+            <a:r>
+              <a:rPr lang="hu-HU" sz="2400" dirty="0"/>
+              <a:t> drónhálózat </a:t>
+            </a:r>
+            <a:r>
+              <a:rPr lang="hu-HU" sz="2400" dirty="0" err="1"/>
+              <a:t>logisztikailag</a:t>
+            </a:r>
+            <a:r>
+              <a:rPr lang="hu-HU" sz="2400" dirty="0"/>
+              <a:t> és pénzügyileg is kivitelezhető, reális megoldást nyújthat a hazai hirtelen szívmegállások túlélési láncának forradalmasítására.</a:t>
+            </a:r>
+          </a:p>
+        </p:txBody>
+      </p:sp>
+      <p:sp>
+        <p:nvSpPr>
+          <p:cNvPr id="82" name="TextBox 81">
+            <a:extLst>
+              <a:ext uri="{FF2B5EF4-FFF2-40B4-BE49-F238E27FC236}">
+                <a16:creationId xmlns:a16="http://schemas.microsoft.com/office/drawing/2014/main" id="{106949C1-DB7A-5055-9B5F-D319F98ACB97}"/>
+              </a:ext>
+            </a:extLst>
+          </p:cNvPr>
+          <p:cNvSpPr txBox="1"/>
+          <p:nvPr/>
+        </p:nvSpPr>
+        <p:spPr>
+          <a:xfrm>
+            <a:off x="17176740" y="28176497"/>
+            <a:ext cx="6937468" cy="5632311"/>
+          </a:xfrm>
+          <a:prstGeom prst="rect">
+            <a:avLst/>
+          </a:prstGeom>
+          <a:noFill/>
+        </p:spPr>
+        <p:txBody>
+          <a:bodyPr wrap="square" rtlCol="0">
+            <a:spAutoFit/>
+          </a:bodyPr>
+          <a:lstStyle/>
+          <a:p>
+            <a:pPr algn="just"/>
+            <a:r>
+              <a:rPr lang="en-US" sz="2400" b="1" dirty="0"/>
+              <a:t>Mathematical optimum:</a:t>
+            </a:r>
+            <a:r>
+              <a:rPr lang="en-US" sz="2400" dirty="0"/>
+              <a:t> During network </a:t>
+            </a:r>
+            <a:r>
+              <a:rPr lang="en-US" sz="2400" dirty="0" err="1"/>
+              <a:t>optimisation</a:t>
+            </a:r>
+            <a:r>
+              <a:rPr lang="en-US" sz="2400" dirty="0"/>
+              <a:t>, the principle of diminishing returns is clearly evident between the drones' operational range and the required number of bases. The ideal equilibrium point (sweet spot) is located at the 16 km operational radius.</a:t>
+            </a:r>
+          </a:p>
+          <a:p>
+            <a:pPr algn="just"/>
+            <a:r>
+              <a:rPr lang="en-US" sz="2400" b="1" dirty="0"/>
+              <a:t>Infrastructure </a:t>
+            </a:r>
+            <a:r>
+              <a:rPr lang="en-US" sz="2400" dirty="0"/>
+              <a:t>requirements: At this point, deploying 140 drone bases is enough to achieve 95% coverage of the national AED demand.</a:t>
+            </a:r>
+          </a:p>
+          <a:p>
+            <a:pPr algn="just"/>
+            <a:r>
+              <a:rPr lang="en-US" sz="2400" b="1" dirty="0"/>
+              <a:t>Final verdict:</a:t>
+            </a:r>
+            <a:r>
+              <a:rPr lang="en-US" sz="2400" dirty="0"/>
+              <a:t> A data-driven drone network based on small-scale UAVs with a 16–20 km operational radius (e.g., VTOL technology) offers a logistically and financially feasible, realistic solution to </a:t>
+            </a:r>
+            <a:r>
+              <a:rPr lang="en-US" sz="2400" dirty="0" err="1"/>
+              <a:t>revolutionise</a:t>
+            </a:r>
+            <a:r>
+              <a:rPr lang="en-US" sz="2400" dirty="0"/>
+              <a:t> the national chain of survival for sudden cardiac arrests.</a:t>
+            </a:r>
+            <a:endParaRPr lang="hu-HU" sz="2400" dirty="0"/>
+          </a:p>
+        </p:txBody>
+      </p:sp>
     </p:spTree>
     <p:extLst>
       <p:ext uri="{BB962C8B-B14F-4D97-AF65-F5344CB8AC3E}">

</xml_diff>